<commit_message>
Module 5: correct the capital breakdown line, order PD before the capital stack
The 2.5% conservation buffer sits on top of the 8% minimum, so the four
tiers do not sum to 89,500. Headline and tile now say so. Slides 4 and 5
swapped so PD, LGD and EAD arrive before the capital calculation, and the
footers are renumbered to match their positions.

Co-Authored-By: Claude Opus 5 <noreply@anthropic.com>
</commit_message>
<xml_diff>
--- a/slides/Module-05-Risk-Modelling.pptx
+++ b/slides/Module-05-Risk-Modelling.pptx
@@ -11,8 +11,8 @@
     <p:sldId id="256" r:id="rId2"/>
     <p:sldId id="257" r:id="rId3"/>
     <p:sldId id="284" r:id="rId4"/>
+    <p:sldId id="258" r:id="rId6"/>
     <p:sldId id="290" r:id="rId5"/>
-    <p:sldId id="258" r:id="rId6"/>
     <p:sldId id="259" r:id="rId7"/>
     <p:sldId id="260" r:id="rId8"/>
     <p:sldId id="261" r:id="rId9"/>
@@ -5340,7 +5340,7 @@
                   <a:srgbClr val="5D6B7E"/>
                 </a:solidFill>
               </a:rPr>
-              <a:t>MODULE 5  ·  08</a:t>
+              <a:t>MODULE 5  ·  10</a:t>
             </a:r>
           </a:p>
         </p:txBody>
@@ -6673,7 +6673,7 @@
                   <a:srgbClr val="5D6B7E"/>
                 </a:solidFill>
               </a:rPr>
-              <a:t>MODULE 5  ·  09</a:t>
+              <a:t>MODULE 5  ·  11</a:t>
             </a:r>
           </a:p>
         </p:txBody>
@@ -8146,7 +8146,7 @@
                   <a:srgbClr val="5D6B7E"/>
                 </a:solidFill>
               </a:rPr>
-              <a:t>MODULE 5  ·  10</a:t>
+              <a:t>MODULE 5  ·  12</a:t>
             </a:r>
           </a:p>
         </p:txBody>
@@ -12456,7 +12456,7 @@
                   <a:srgbClr val="1B2A4A"/>
                 </a:solidFill>
               </a:rPr>
-              <a:t>Now break down that ₹89,500 Crore capital into Basel III tiers:</a:t>
+              <a:t>Now break down that ₹89,500 Crore MINIMUM into Basel III tiers — the buffer sits on top of it:</a:t>
             </a:r>
             <a:endParaRPr lang="en-US" sz="1600" dirty="0"/>
           </a:p>
@@ -12992,7 +12992,7 @@
                   <a:srgbClr val="64748B"/>
                 </a:solidFill>
               </a:rPr>
-              <a:t>Conservation buffer</a:t>
+              <a:t>Conservation buffer — extra, on top of the 8%</a:t>
             </a:r>
             <a:endParaRPr lang="en-US" sz="1200" dirty="0"/>
           </a:p>
@@ -14407,7 +14407,7 @@
                   <a:srgbClr val="5D6B7E"/>
                 </a:solidFill>
               </a:rPr>
-              <a:t>MODULE 5  ·  03</a:t>
+              <a:t>MODULE 5  ·  04</a:t>
             </a:r>
           </a:p>
         </p:txBody>
@@ -15491,7 +15491,7 @@
                   <a:srgbClr val="5D6B7E"/>
                 </a:solidFill>
               </a:rPr>
-              <a:t>MODULE 5  ·  04</a:t>
+              <a:t>MODULE 5  ·  06</a:t>
             </a:r>
           </a:p>
         </p:txBody>
@@ -16726,7 +16726,7 @@
                   <a:srgbClr val="5D6B7E"/>
                 </a:solidFill>
               </a:rPr>
-              <a:t>MODULE 5  ·  05</a:t>
+              <a:t>MODULE 5  ·  07</a:t>
             </a:r>
           </a:p>
         </p:txBody>
@@ -17824,7 +17824,7 @@
                   <a:srgbClr val="5D6B7E"/>
                 </a:solidFill>
               </a:rPr>
-              <a:t>MODULE 5  ·  06</a:t>
+              <a:t>MODULE 5  ·  08</a:t>
             </a:r>
           </a:p>
         </p:txBody>

</xml_diff>